<commit_message>
Updated sort notes again
</commit_message>
<xml_diff>
--- a/u10b_sorts/notes/n2sorts.pptx
+++ b/u10b_sorts/notes/n2sorts.pptx
@@ -5,10 +5,10 @@
     <p:sldMasterId id="2147483648" r:id="rId1"/>
   </p:sldMasterIdLst>
   <p:notesMasterIdLst>
-    <p:notesMasterId r:id="rId38"/>
+    <p:notesMasterId r:id="rId39"/>
   </p:notesMasterIdLst>
   <p:handoutMasterIdLst>
-    <p:handoutMasterId r:id="rId39"/>
+    <p:handoutMasterId r:id="rId40"/>
   </p:handoutMasterIdLst>
   <p:sldIdLst>
     <p:sldId id="256" r:id="rId2"/>
@@ -39,19 +39,20 @@
     <p:sldId id="415" r:id="rId27"/>
     <p:sldId id="432" r:id="rId28"/>
     <p:sldId id="398" r:id="rId29"/>
-    <p:sldId id="430" r:id="rId30"/>
-    <p:sldId id="347" r:id="rId31"/>
-    <p:sldId id="354" r:id="rId32"/>
-    <p:sldId id="357" r:id="rId33"/>
-    <p:sldId id="427" r:id="rId34"/>
-    <p:sldId id="414" r:id="rId35"/>
-    <p:sldId id="428" r:id="rId36"/>
-    <p:sldId id="418" r:id="rId37"/>
+    <p:sldId id="434" r:id="rId30"/>
+    <p:sldId id="430" r:id="rId31"/>
+    <p:sldId id="347" r:id="rId32"/>
+    <p:sldId id="354" r:id="rId33"/>
+    <p:sldId id="357" r:id="rId34"/>
+    <p:sldId id="427" r:id="rId35"/>
+    <p:sldId id="414" r:id="rId36"/>
+    <p:sldId id="428" r:id="rId37"/>
+    <p:sldId id="418" r:id="rId38"/>
   </p:sldIdLst>
   <p:sldSz cx="9144000" cy="6858000" type="screen4x3"/>
   <p:notesSz cx="6858000" cy="9144000"/>
   <p:custDataLst>
-    <p:tags r:id="rId40"/>
+    <p:tags r:id="rId41"/>
   </p:custDataLst>
   <p:defaultTextStyle>
     <a:defPPr>
@@ -2522,6 +2523,112 @@
 </file>
 
 <file path=ppt/notesSlides/notesSlide25.xml><?xml version="1.0" encoding="utf-8"?>
+<p:notes xmlns:a="http://schemas.openxmlformats.org/drawingml/2006/main" xmlns:r="http://schemas.openxmlformats.org/officeDocument/2006/relationships" xmlns:p="http://schemas.openxmlformats.org/presentationml/2006/main">
+  <p:cSld>
+    <p:spTree>
+      <p:nvGrpSpPr>
+        <p:cNvPr id="1" name=""/>
+        <p:cNvGrpSpPr/>
+        <p:nvPr/>
+      </p:nvGrpSpPr>
+      <p:grpSpPr>
+        <a:xfrm>
+          <a:off x="0" y="0"/>
+          <a:ext cx="0" cy="0"/>
+          <a:chOff x="0" y="0"/>
+          <a:chExt cx="0" cy="0"/>
+        </a:xfrm>
+      </p:grpSpPr>
+      <p:sp>
+        <p:nvSpPr>
+          <p:cNvPr id="45058" name="Rectangle 2">
+            <a:extLst>
+              <a:ext uri="{FF2B5EF4-FFF2-40B4-BE49-F238E27FC236}">
+                <a16:creationId xmlns:a16="http://schemas.microsoft.com/office/drawing/2014/main" id="{7CB7E560-3407-4499-8C22-334BBED17EE5}"/>
+              </a:ext>
+            </a:extLst>
+          </p:cNvPr>
+          <p:cNvSpPr>
+            <a:spLocks noGrp="1" noRot="1" noChangeAspect="1" noChangeArrowheads="1" noTextEdit="1"/>
+          </p:cNvSpPr>
+          <p:nvPr>
+            <p:ph type="sldImg"/>
+          </p:nvPr>
+        </p:nvSpPr>
+        <p:spPr>
+          <a:ln/>
+        </p:spPr>
+      </p:sp>
+      <p:sp>
+        <p:nvSpPr>
+          <p:cNvPr id="45059" name="Rectangle 3">
+            <a:extLst>
+              <a:ext uri="{FF2B5EF4-FFF2-40B4-BE49-F238E27FC236}">
+                <a16:creationId xmlns:a16="http://schemas.microsoft.com/office/drawing/2014/main" id="{A999CC00-7437-48F4-8C8A-80097D6A1A81}"/>
+              </a:ext>
+            </a:extLst>
+          </p:cNvPr>
+          <p:cNvSpPr>
+            <a:spLocks noGrp="1" noChangeArrowheads="1"/>
+          </p:cNvSpPr>
+          <p:nvPr>
+            <p:ph type="body" idx="1"/>
+          </p:nvPr>
+        </p:nvSpPr>
+        <p:spPr>
+          <a:noFill/>
+        </p:spPr>
+        <p:txBody>
+          <a:bodyPr/>
+          <a:lstStyle/>
+          <a:p>
+            <a:pPr marL="0" marR="0" lvl="0" indent="0" algn="l" defTabSz="914400" rtl="0" eaLnBrk="0" fontAlgn="base" latinLnBrk="0" hangingPunct="0">
+              <a:lnSpc>
+                <a:spcPct val="100000"/>
+              </a:lnSpc>
+              <a:spcBef>
+                <a:spcPct val="30000"/>
+              </a:spcBef>
+              <a:spcAft>
+                <a:spcPct val="0"/>
+              </a:spcAft>
+              <a:buClrTx/>
+              <a:buSzTx/>
+              <a:buFontTx/>
+              <a:buNone/>
+              <a:tabLst/>
+              <a:defRPr/>
+            </a:pPr>
+            <a:r>
+              <a:rPr lang="en-US" b="0" i="0" dirty="0">
+                <a:solidFill>
+                  <a:srgbClr val="001D35"/>
+                </a:solidFill>
+                <a:effectLst/>
+                <a:latin typeface="Google Sans"/>
+              </a:rPr>
+              <a:t>This is because comparing objects involves evaluating their properties, which can be a time-consuming process, especially when you need to check for equality on a deep level by traversing nested objects or comparing arrays. </a:t>
+            </a:r>
+          </a:p>
+          <a:p>
+            <a:endParaRPr lang="en-US" altLang="en-US" dirty="0"/>
+          </a:p>
+        </p:txBody>
+      </p:sp>
+    </p:spTree>
+    <p:extLst>
+      <p:ext uri="{BB962C8B-B14F-4D97-AF65-F5344CB8AC3E}">
+        <p14:creationId xmlns:p14="http://schemas.microsoft.com/office/powerpoint/2010/main" val="3055285615"/>
+      </p:ext>
+    </p:extLst>
+  </p:cSld>
+  <p:clrMapOvr>
+    <a:masterClrMapping/>
+  </p:clrMapOvr>
+</p:notes>
+</file>
+
+<file path=ppt/notesSlides/notesSlide26.xml><?xml version="1.0" encoding="utf-8"?>
 <p:notes xmlns:a="http://schemas.openxmlformats.org/drawingml/2006/main" xmlns:r="http://schemas.openxmlformats.org/officeDocument/2006/relationships" xmlns:p="http://schemas.openxmlformats.org/presentationml/2006/main" showMasterSp="0" showMasterPhAnim="0">
   <p:cSld>
     <p:spTree>
@@ -2625,7 +2732,7 @@
 </p:notes>
 </file>
 
-<file path=ppt/notesSlides/notesSlide26.xml><?xml version="1.0" encoding="utf-8"?>
+<file path=ppt/notesSlides/notesSlide27.xml><?xml version="1.0" encoding="utf-8"?>
 <p:notes xmlns:a="http://schemas.openxmlformats.org/drawingml/2006/main" xmlns:r="http://schemas.openxmlformats.org/officeDocument/2006/relationships" xmlns:p="http://schemas.openxmlformats.org/presentationml/2006/main" showMasterSp="0" showMasterPhAnim="0">
   <p:cSld>
     <p:spTree>
@@ -2729,7 +2836,7 @@
 </p:notes>
 </file>
 
-<file path=ppt/notesSlides/notesSlide27.xml><?xml version="1.0" encoding="utf-8"?>
+<file path=ppt/notesSlides/notesSlide28.xml><?xml version="1.0" encoding="utf-8"?>
 <p:notes xmlns:a="http://schemas.openxmlformats.org/drawingml/2006/main" xmlns:r="http://schemas.openxmlformats.org/officeDocument/2006/relationships" xmlns:p="http://schemas.openxmlformats.org/presentationml/2006/main" showMasterSp="0" showMasterPhAnim="0">
   <p:cSld>
     <p:spTree>
@@ -2833,7 +2940,7 @@
 </p:notes>
 </file>
 
-<file path=ppt/notesSlides/notesSlide28.xml><?xml version="1.0" encoding="utf-8"?>
+<file path=ppt/notesSlides/notesSlide29.xml><?xml version="1.0" encoding="utf-8"?>
 <p:notes xmlns:a="http://schemas.openxmlformats.org/drawingml/2006/main" xmlns:r="http://schemas.openxmlformats.org/officeDocument/2006/relationships" xmlns:p="http://schemas.openxmlformats.org/presentationml/2006/main">
   <p:cSld>
     <p:spTree>
@@ -41069,6 +41176,714 @@
 <file path=ppt/slides/slide29.xml><?xml version="1.0" encoding="utf-8"?>
 <p:sld xmlns:a="http://schemas.openxmlformats.org/drawingml/2006/main" xmlns:r="http://schemas.openxmlformats.org/officeDocument/2006/relationships" xmlns:p="http://schemas.openxmlformats.org/presentationml/2006/main">
   <p:cSld>
+    <p:spTree>
+      <p:nvGrpSpPr>
+        <p:cNvPr id="1" name=""/>
+        <p:cNvGrpSpPr/>
+        <p:nvPr/>
+      </p:nvGrpSpPr>
+      <p:grpSpPr>
+        <a:xfrm>
+          <a:off x="0" y="0"/>
+          <a:ext cx="0" cy="0"/>
+          <a:chOff x="0" y="0"/>
+          <a:chExt cx="0" cy="0"/>
+        </a:xfrm>
+      </p:grpSpPr>
+      <p:sp>
+        <p:nvSpPr>
+          <p:cNvPr id="44035" name="Text Box 2">
+            <a:extLst>
+              <a:ext uri="{FF2B5EF4-FFF2-40B4-BE49-F238E27FC236}">
+                <a16:creationId xmlns:a16="http://schemas.microsoft.com/office/drawing/2014/main" id="{D6CADE04-6131-4646-BE47-10C84C1D41B6}"/>
+              </a:ext>
+            </a:extLst>
+          </p:cNvPr>
+          <p:cNvSpPr txBox="1">
+            <a:spLocks noChangeArrowheads="1"/>
+          </p:cNvSpPr>
+          <p:nvPr/>
+        </p:nvSpPr>
+        <p:spPr bwMode="auto">
+          <a:xfrm>
+            <a:off x="838200" y="533400"/>
+            <a:ext cx="7756525" cy="990015"/>
+          </a:xfrm>
+          <a:prstGeom prst="rect">
+            <a:avLst/>
+          </a:prstGeom>
+          <a:noFill/>
+          <a:ln>
+            <a:noFill/>
+          </a:ln>
+          <a:effectLst/>
+          <a:extLst>
+            <a:ext uri="{909E8E84-426E-40DD-AFC4-6F175D3DCCD1}">
+              <a14:hiddenFill xmlns:a14="http://schemas.microsoft.com/office/drawing/2010/main">
+                <a:solidFill>
+                  <a:schemeClr val="accent1"/>
+                </a:solidFill>
+              </a14:hiddenFill>
+            </a:ext>
+            <a:ext uri="{91240B29-F687-4F45-9708-019B960494DF}">
+              <a14:hiddenLine xmlns:a14="http://schemas.microsoft.com/office/drawing/2010/main" w="9525">
+                <a:solidFill>
+                  <a:schemeClr val="tx1"/>
+                </a:solidFill>
+                <a:miter lim="800000"/>
+                <a:headEnd/>
+                <a:tailEnd/>
+              </a14:hiddenLine>
+            </a:ext>
+            <a:ext uri="{AF507438-7753-43E0-B8FC-AC1667EBCBE1}">
+              <a14:hiddenEffects xmlns:a14="http://schemas.microsoft.com/office/drawing/2010/main">
+                <a:effectLst>
+                  <a:outerShdw dist="35921" dir="2700000" algn="ctr" rotWithShape="0">
+                    <a:schemeClr val="bg2"/>
+                  </a:outerShdw>
+                </a:effectLst>
+              </a14:hiddenEffects>
+            </a:ext>
+          </a:extLst>
+        </p:spPr>
+        <p:txBody>
+          <a:bodyPr>
+            <a:spAutoFit/>
+          </a:bodyPr>
+          <a:lstStyle>
+            <a:lvl1pPr>
+              <a:spcBef>
+                <a:spcPct val="20000"/>
+              </a:spcBef>
+              <a:buChar char="•"/>
+              <a:defRPr sz="3200">
+                <a:solidFill>
+                  <a:schemeClr val="tx1"/>
+                </a:solidFill>
+                <a:latin typeface="Times New Roman" panose="02020603050405020304" pitchFamily="18" charset="0"/>
+              </a:defRPr>
+            </a:lvl1pPr>
+            <a:lvl2pPr marL="742950" indent="-285750">
+              <a:spcBef>
+                <a:spcPct val="20000"/>
+              </a:spcBef>
+              <a:buChar char="–"/>
+              <a:defRPr sz="2800">
+                <a:solidFill>
+                  <a:schemeClr val="tx1"/>
+                </a:solidFill>
+                <a:latin typeface="Times New Roman" panose="02020603050405020304" pitchFamily="18" charset="0"/>
+              </a:defRPr>
+            </a:lvl2pPr>
+            <a:lvl3pPr marL="1143000" indent="-228600">
+              <a:spcBef>
+                <a:spcPct val="20000"/>
+              </a:spcBef>
+              <a:buChar char="•"/>
+              <a:defRPr sz="2400">
+                <a:solidFill>
+                  <a:schemeClr val="tx1"/>
+                </a:solidFill>
+                <a:latin typeface="Times New Roman" panose="02020603050405020304" pitchFamily="18" charset="0"/>
+              </a:defRPr>
+            </a:lvl3pPr>
+            <a:lvl4pPr marL="1600200" indent="-228600">
+              <a:spcBef>
+                <a:spcPct val="20000"/>
+              </a:spcBef>
+              <a:buChar char="–"/>
+              <a:defRPr sz="2000">
+                <a:solidFill>
+                  <a:schemeClr val="tx1"/>
+                </a:solidFill>
+                <a:latin typeface="Times New Roman" panose="02020603050405020304" pitchFamily="18" charset="0"/>
+              </a:defRPr>
+            </a:lvl4pPr>
+            <a:lvl5pPr marL="2057400" indent="-228600">
+              <a:spcBef>
+                <a:spcPct val="20000"/>
+              </a:spcBef>
+              <a:buChar char="»"/>
+              <a:defRPr sz="2000">
+                <a:solidFill>
+                  <a:schemeClr val="tx1"/>
+                </a:solidFill>
+                <a:latin typeface="Times New Roman" panose="02020603050405020304" pitchFamily="18" charset="0"/>
+              </a:defRPr>
+            </a:lvl5pPr>
+            <a:lvl6pPr marL="2514600" indent="-228600" eaLnBrk="0" fontAlgn="base" hangingPunct="0">
+              <a:spcBef>
+                <a:spcPct val="20000"/>
+              </a:spcBef>
+              <a:spcAft>
+                <a:spcPct val="0"/>
+              </a:spcAft>
+              <a:buChar char="»"/>
+              <a:defRPr sz="2000">
+                <a:solidFill>
+                  <a:schemeClr val="tx1"/>
+                </a:solidFill>
+                <a:latin typeface="Times New Roman" panose="02020603050405020304" pitchFamily="18" charset="0"/>
+              </a:defRPr>
+            </a:lvl6pPr>
+            <a:lvl7pPr marL="2971800" indent="-228600" eaLnBrk="0" fontAlgn="base" hangingPunct="0">
+              <a:spcBef>
+                <a:spcPct val="20000"/>
+              </a:spcBef>
+              <a:spcAft>
+                <a:spcPct val="0"/>
+              </a:spcAft>
+              <a:buChar char="»"/>
+              <a:defRPr sz="2000">
+                <a:solidFill>
+                  <a:schemeClr val="tx1"/>
+                </a:solidFill>
+                <a:latin typeface="Times New Roman" panose="02020603050405020304" pitchFamily="18" charset="0"/>
+              </a:defRPr>
+            </a:lvl7pPr>
+            <a:lvl8pPr marL="3429000" indent="-228600" eaLnBrk="0" fontAlgn="base" hangingPunct="0">
+              <a:spcBef>
+                <a:spcPct val="20000"/>
+              </a:spcBef>
+              <a:spcAft>
+                <a:spcPct val="0"/>
+              </a:spcAft>
+              <a:buChar char="»"/>
+              <a:defRPr sz="2000">
+                <a:solidFill>
+                  <a:schemeClr val="tx1"/>
+                </a:solidFill>
+                <a:latin typeface="Times New Roman" panose="02020603050405020304" pitchFamily="18" charset="0"/>
+              </a:defRPr>
+            </a:lvl8pPr>
+            <a:lvl9pPr marL="3886200" indent="-228600" eaLnBrk="0" fontAlgn="base" hangingPunct="0">
+              <a:spcBef>
+                <a:spcPct val="20000"/>
+              </a:spcBef>
+              <a:spcAft>
+                <a:spcPct val="0"/>
+              </a:spcAft>
+              <a:buChar char="»"/>
+              <a:defRPr sz="2000">
+                <a:solidFill>
+                  <a:schemeClr val="tx1"/>
+                </a:solidFill>
+                <a:latin typeface="Times New Roman" panose="02020603050405020304" pitchFamily="18" charset="0"/>
+              </a:defRPr>
+            </a:lvl9pPr>
+          </a:lstStyle>
+          <a:p>
+            <a:pPr algn="ctr">
+              <a:lnSpc>
+                <a:spcPts val="3500"/>
+              </a:lnSpc>
+              <a:spcBef>
+                <a:spcPct val="0"/>
+              </a:spcBef>
+              <a:buFontTx/>
+              <a:buNone/>
+            </a:pPr>
+            <a:r>
+              <a:rPr lang="en-US" altLang="en-US" sz="3600" dirty="0">
+                <a:latin typeface="Tahoma" panose="020B0604030504040204" pitchFamily="34" charset="0"/>
+              </a:rPr>
+              <a:t>When would binary search help insertion sort run faster?</a:t>
+            </a:r>
+          </a:p>
+        </p:txBody>
+      </p:sp>
+      <p:sp>
+        <p:nvSpPr>
+          <p:cNvPr id="44034" name="Footer Placeholder 3">
+            <a:extLst>
+              <a:ext uri="{FF2B5EF4-FFF2-40B4-BE49-F238E27FC236}">
+                <a16:creationId xmlns:a16="http://schemas.microsoft.com/office/drawing/2014/main" id="{FC290699-4760-45EC-B1A4-011A50C5C522}"/>
+              </a:ext>
+              <a:ext uri="{C183D7F6-B498-43B3-948B-1728B52AA6E4}">
+                <adec:decorative xmlns:adec="http://schemas.microsoft.com/office/drawing/2017/decorative" val="1"/>
+              </a:ext>
+            </a:extLst>
+          </p:cNvPr>
+          <p:cNvSpPr>
+            <a:spLocks noGrp="1"/>
+          </p:cNvSpPr>
+          <p:nvPr>
+            <p:ph type="ftr" sz="quarter" idx="12"/>
+          </p:nvPr>
+        </p:nvSpPr>
+        <p:spPr>
+          <a:noFill/>
+        </p:spPr>
+        <p:txBody>
+          <a:bodyPr/>
+          <a:lstStyle>
+            <a:lvl1pPr>
+              <a:spcBef>
+                <a:spcPct val="20000"/>
+              </a:spcBef>
+              <a:buChar char="•"/>
+              <a:defRPr sz="3200">
+                <a:solidFill>
+                  <a:schemeClr val="tx1"/>
+                </a:solidFill>
+                <a:latin typeface="Times New Roman" panose="02020603050405020304" pitchFamily="18" charset="0"/>
+              </a:defRPr>
+            </a:lvl1pPr>
+            <a:lvl2pPr marL="742950" indent="-285750">
+              <a:spcBef>
+                <a:spcPct val="20000"/>
+              </a:spcBef>
+              <a:buChar char="–"/>
+              <a:defRPr sz="2800">
+                <a:solidFill>
+                  <a:schemeClr val="tx1"/>
+                </a:solidFill>
+                <a:latin typeface="Times New Roman" panose="02020603050405020304" pitchFamily="18" charset="0"/>
+              </a:defRPr>
+            </a:lvl2pPr>
+            <a:lvl3pPr marL="1143000" indent="-228600">
+              <a:spcBef>
+                <a:spcPct val="20000"/>
+              </a:spcBef>
+              <a:buChar char="•"/>
+              <a:defRPr sz="2400">
+                <a:solidFill>
+                  <a:schemeClr val="tx1"/>
+                </a:solidFill>
+                <a:latin typeface="Times New Roman" panose="02020603050405020304" pitchFamily="18" charset="0"/>
+              </a:defRPr>
+            </a:lvl3pPr>
+            <a:lvl4pPr marL="1600200" indent="-228600">
+              <a:spcBef>
+                <a:spcPct val="20000"/>
+              </a:spcBef>
+              <a:buChar char="–"/>
+              <a:defRPr sz="2000">
+                <a:solidFill>
+                  <a:schemeClr val="tx1"/>
+                </a:solidFill>
+                <a:latin typeface="Times New Roman" panose="02020603050405020304" pitchFamily="18" charset="0"/>
+              </a:defRPr>
+            </a:lvl4pPr>
+            <a:lvl5pPr marL="2057400" indent="-228600">
+              <a:spcBef>
+                <a:spcPct val="20000"/>
+              </a:spcBef>
+              <a:buChar char="»"/>
+              <a:defRPr sz="2000">
+                <a:solidFill>
+                  <a:schemeClr val="tx1"/>
+                </a:solidFill>
+                <a:latin typeface="Times New Roman" panose="02020603050405020304" pitchFamily="18" charset="0"/>
+              </a:defRPr>
+            </a:lvl5pPr>
+            <a:lvl6pPr marL="2514600" indent="-228600" eaLnBrk="0" fontAlgn="base" hangingPunct="0">
+              <a:spcBef>
+                <a:spcPct val="20000"/>
+              </a:spcBef>
+              <a:spcAft>
+                <a:spcPct val="0"/>
+              </a:spcAft>
+              <a:buChar char="»"/>
+              <a:defRPr sz="2000">
+                <a:solidFill>
+                  <a:schemeClr val="tx1"/>
+                </a:solidFill>
+                <a:latin typeface="Times New Roman" panose="02020603050405020304" pitchFamily="18" charset="0"/>
+              </a:defRPr>
+            </a:lvl6pPr>
+            <a:lvl7pPr marL="2971800" indent="-228600" eaLnBrk="0" fontAlgn="base" hangingPunct="0">
+              <a:spcBef>
+                <a:spcPct val="20000"/>
+              </a:spcBef>
+              <a:spcAft>
+                <a:spcPct val="0"/>
+              </a:spcAft>
+              <a:buChar char="»"/>
+              <a:defRPr sz="2000">
+                <a:solidFill>
+                  <a:schemeClr val="tx1"/>
+                </a:solidFill>
+                <a:latin typeface="Times New Roman" panose="02020603050405020304" pitchFamily="18" charset="0"/>
+              </a:defRPr>
+            </a:lvl7pPr>
+            <a:lvl8pPr marL="3429000" indent="-228600" eaLnBrk="0" fontAlgn="base" hangingPunct="0">
+              <a:spcBef>
+                <a:spcPct val="20000"/>
+              </a:spcBef>
+              <a:spcAft>
+                <a:spcPct val="0"/>
+              </a:spcAft>
+              <a:buChar char="»"/>
+              <a:defRPr sz="2000">
+                <a:solidFill>
+                  <a:schemeClr val="tx1"/>
+                </a:solidFill>
+                <a:latin typeface="Times New Roman" panose="02020603050405020304" pitchFamily="18" charset="0"/>
+              </a:defRPr>
+            </a:lvl8pPr>
+            <a:lvl9pPr marL="3886200" indent="-228600" eaLnBrk="0" fontAlgn="base" hangingPunct="0">
+              <a:spcBef>
+                <a:spcPct val="20000"/>
+              </a:spcBef>
+              <a:spcAft>
+                <a:spcPct val="0"/>
+              </a:spcAft>
+              <a:buChar char="»"/>
+              <a:defRPr sz="2000">
+                <a:solidFill>
+                  <a:schemeClr val="tx1"/>
+                </a:solidFill>
+                <a:latin typeface="Times New Roman" panose="02020603050405020304" pitchFamily="18" charset="0"/>
+              </a:defRPr>
+            </a:lvl9pPr>
+          </a:lstStyle>
+          <a:p>
+            <a:pPr>
+              <a:lnSpc>
+                <a:spcPts val="3500"/>
+              </a:lnSpc>
+              <a:spcBef>
+                <a:spcPct val="0"/>
+              </a:spcBef>
+              <a:buFontTx/>
+              <a:buNone/>
+            </a:pPr>
+            <a:endParaRPr lang="en-US" altLang="en-US" sz="700"/>
+          </a:p>
+          <a:p>
+            <a:pPr>
+              <a:lnSpc>
+                <a:spcPts val="3500"/>
+              </a:lnSpc>
+              <a:spcBef>
+                <a:spcPct val="0"/>
+              </a:spcBef>
+              <a:buFontTx/>
+              <a:buNone/>
+            </a:pPr>
+            <a:endParaRPr lang="en-US" altLang="en-US" sz="700" b="0">
+              <a:latin typeface="Tahoma" panose="020B0604030504040204" pitchFamily="34" charset="0"/>
+            </a:endParaRPr>
+          </a:p>
+          <a:p>
+            <a:pPr>
+              <a:lnSpc>
+                <a:spcPts val="3500"/>
+              </a:lnSpc>
+              <a:spcBef>
+                <a:spcPct val="0"/>
+              </a:spcBef>
+              <a:buFontTx/>
+              <a:buNone/>
+            </a:pPr>
+            <a:endParaRPr lang="en-US" altLang="en-US" sz="700">
+              <a:latin typeface="Tahoma" panose="020B0604030504040204" pitchFamily="34" charset="0"/>
+            </a:endParaRPr>
+          </a:p>
+          <a:p>
+            <a:pPr>
+              <a:lnSpc>
+                <a:spcPts val="3500"/>
+              </a:lnSpc>
+              <a:spcBef>
+                <a:spcPct val="0"/>
+              </a:spcBef>
+              <a:buFontTx/>
+              <a:buNone/>
+            </a:pPr>
+            <a:r>
+              <a:rPr lang="en-US" altLang="en-US" sz="700">
+                <a:latin typeface="Tahoma" panose="020B0604030504040204" pitchFamily="34" charset="0"/>
+              </a:rPr>
+              <a:t>© A+ Computer Science  -  www.apluscompsci.com</a:t>
+            </a:r>
+          </a:p>
+        </p:txBody>
+      </p:sp>
+      <p:sp>
+        <p:nvSpPr>
+          <p:cNvPr id="3" name="TextBox 2">
+            <a:extLst>
+              <a:ext uri="{FF2B5EF4-FFF2-40B4-BE49-F238E27FC236}">
+                <a16:creationId xmlns:a16="http://schemas.microsoft.com/office/drawing/2014/main" id="{164B5EE6-356F-2627-98AB-0466DCF2770A}"/>
+              </a:ext>
+            </a:extLst>
+          </p:cNvPr>
+          <p:cNvSpPr txBox="1"/>
+          <p:nvPr/>
+        </p:nvSpPr>
+        <p:spPr>
+          <a:xfrm>
+            <a:off x="533400" y="2667000"/>
+            <a:ext cx="8305800" cy="1938992"/>
+          </a:xfrm>
+          <a:prstGeom prst="rect">
+            <a:avLst/>
+          </a:prstGeom>
+          <a:noFill/>
+        </p:spPr>
+        <p:txBody>
+          <a:bodyPr wrap="square">
+            <a:spAutoFit/>
+          </a:bodyPr>
+          <a:lstStyle/>
+          <a:p>
+            <a:pPr algn="l" fontAlgn="ctr">
+              <a:buNone/>
+            </a:pPr>
+            <a:r>
+              <a:rPr lang="en-US" sz="4000" b="0" i="0" dirty="0">
+                <a:solidFill>
+                  <a:srgbClr val="001D35"/>
+                </a:solidFill>
+                <a:effectLst/>
+                <a:latin typeface="Google Sans"/>
+              </a:rPr>
+              <a:t>When </a:t>
+            </a:r>
+            <a:r>
+              <a:rPr lang="en-US" sz="4000" b="0" dirty="0">
+                <a:solidFill>
+                  <a:srgbClr val="001D35"/>
+                </a:solidFill>
+                <a:latin typeface="Google Sans"/>
+              </a:rPr>
+              <a:t>c</a:t>
+            </a:r>
+            <a:r>
+              <a:rPr lang="en-US" sz="4000" b="0" i="0" dirty="0">
+                <a:solidFill>
+                  <a:srgbClr val="001D35"/>
+                </a:solidFill>
+                <a:effectLst/>
+                <a:latin typeface="Google Sans"/>
+              </a:rPr>
+              <a:t>omparing objects is expensive, such as when doing a deep comparison with large or complex objects. </a:t>
+            </a:r>
+          </a:p>
+        </p:txBody>
+      </p:sp>
+    </p:spTree>
+    <p:extLst>
+      <p:ext uri="{BB962C8B-B14F-4D97-AF65-F5344CB8AC3E}">
+        <p14:creationId xmlns:p14="http://schemas.microsoft.com/office/powerpoint/2010/main" val="3757986929"/>
+      </p:ext>
+    </p:extLst>
+  </p:cSld>
+  <p:clrMapOvr>
+    <a:masterClrMapping/>
+  </p:clrMapOvr>
+  <p:timing>
+    <p:tnLst>
+      <p:par>
+        <p:cTn id="1" dur="indefinite" restart="never" nodeType="tmRoot">
+          <p:childTnLst>
+            <p:seq concurrent="1" nextAc="seek">
+              <p:cTn id="2" dur="indefinite" nodeType="mainSeq">
+                <p:childTnLst>
+                  <p:par>
+                    <p:cTn id="3" fill="hold">
+                      <p:stCondLst>
+                        <p:cond delay="indefinite"/>
+                      </p:stCondLst>
+                      <p:childTnLst>
+                        <p:par>
+                          <p:cTn id="4" fill="hold">
+                            <p:stCondLst>
+                              <p:cond delay="0"/>
+                            </p:stCondLst>
+                            <p:childTnLst>
+                              <p:par>
+                                <p:cTn id="5" presetID="1" presetClass="entr" presetSubtype="0" fill="hold" grpId="0" nodeType="clickEffect">
+                                  <p:stCondLst>
+                                    <p:cond delay="0"/>
+                                  </p:stCondLst>
+                                  <p:childTnLst>
+                                    <p:set>
+                                      <p:cBhvr>
+                                        <p:cTn id="6" dur="1" fill="hold">
+                                          <p:stCondLst>
+                                            <p:cond delay="0"/>
+                                          </p:stCondLst>
+                                        </p:cTn>
+                                        <p:tgtEl>
+                                          <p:spTgt spid="3"/>
+                                        </p:tgtEl>
+                                        <p:attrNameLst>
+                                          <p:attrName>style.visibility</p:attrName>
+                                        </p:attrNameLst>
+                                      </p:cBhvr>
+                                      <p:to>
+                                        <p:strVal val="visible"/>
+                                      </p:to>
+                                    </p:set>
+                                  </p:childTnLst>
+                                </p:cTn>
+                              </p:par>
+                            </p:childTnLst>
+                          </p:cTn>
+                        </p:par>
+                      </p:childTnLst>
+                    </p:cTn>
+                  </p:par>
+                </p:childTnLst>
+              </p:cTn>
+              <p:prevCondLst>
+                <p:cond evt="onPrev" delay="0">
+                  <p:tgtEl>
+                    <p:sldTgt/>
+                  </p:tgtEl>
+                </p:cond>
+              </p:prevCondLst>
+              <p:nextCondLst>
+                <p:cond evt="onNext" delay="0">
+                  <p:tgtEl>
+                    <p:sldTgt/>
+                  </p:tgtEl>
+                </p:cond>
+              </p:nextCondLst>
+            </p:seq>
+          </p:childTnLst>
+        </p:cTn>
+      </p:par>
+    </p:tnLst>
+    <p:bldLst>
+      <p:bldP spid="3" grpId="0"/>
+    </p:bldLst>
+  </p:timing>
+</p:sld>
+</file>
+
+<file path=ppt/slides/slide3.xml><?xml version="1.0" encoding="utf-8"?>
+<p:sld xmlns:a="http://schemas.openxmlformats.org/drawingml/2006/main" xmlns:r="http://schemas.openxmlformats.org/officeDocument/2006/relationships" xmlns:p="http://schemas.openxmlformats.org/presentationml/2006/main">
+  <p:cSld>
+    <p:spTree>
+      <p:nvGrpSpPr>
+        <p:cNvPr id="1" name=""/>
+        <p:cNvGrpSpPr/>
+        <p:nvPr/>
+      </p:nvGrpSpPr>
+      <p:grpSpPr>
+        <a:xfrm>
+          <a:off x="0" y="0"/>
+          <a:ext cx="0" cy="0"/>
+          <a:chOff x="0" y="0"/>
+          <a:chExt cx="0" cy="0"/>
+        </a:xfrm>
+      </p:grpSpPr>
+      <p:sp>
+        <p:nvSpPr>
+          <p:cNvPr id="7171" name="Rectangle 2"/>
+          <p:cNvSpPr>
+            <a:spLocks noGrp="1" noChangeArrowheads="1"/>
+          </p:cNvSpPr>
+          <p:nvPr>
+            <p:ph type="title"/>
+          </p:nvPr>
+        </p:nvSpPr>
+        <p:spPr>
+          <a:xfrm>
+            <a:off x="152400" y="609600"/>
+            <a:ext cx="8686800" cy="1143000"/>
+          </a:xfrm>
+        </p:spPr>
+        <p:txBody>
+          <a:bodyPr/>
+          <a:lstStyle/>
+          <a:p>
+            <a:r>
+              <a:rPr lang="en-US" dirty="0">
+                <a:latin typeface="Arial" panose="020B0604020202020204" pitchFamily="34" charset="0"/>
+                <a:cs typeface="Arial" panose="020B0604020202020204" pitchFamily="34" charset="0"/>
+              </a:rPr>
+              <a:t>Examples of sorting applications:</a:t>
+            </a:r>
+          </a:p>
+        </p:txBody>
+      </p:sp>
+      <p:sp>
+        <p:nvSpPr>
+          <p:cNvPr id="7172" name="Rectangle 3"/>
+          <p:cNvSpPr>
+            <a:spLocks noGrp="1" noChangeArrowheads="1"/>
+          </p:cNvSpPr>
+          <p:nvPr>
+            <p:ph type="body" sz="half" idx="1"/>
+          </p:nvPr>
+        </p:nvSpPr>
+        <p:spPr>
+          <a:xfrm>
+            <a:off x="0" y="1885950"/>
+            <a:ext cx="8991600" cy="4514850"/>
+          </a:xfrm>
+        </p:spPr>
+        <p:txBody>
+          <a:bodyPr/>
+          <a:lstStyle/>
+          <a:p>
+            <a:pPr lvl="1"/>
+            <a:r>
+              <a:rPr lang="en-US" sz="3200" dirty="0">
+                <a:latin typeface="Arial" panose="020B0604020202020204" pitchFamily="34" charset="0"/>
+                <a:cs typeface="Arial" panose="020B0604020202020204" pitchFamily="34" charset="0"/>
+              </a:rPr>
+              <a:t>a directory of files sorted by name or date</a:t>
+            </a:r>
+          </a:p>
+          <a:p>
+            <a:pPr lvl="1"/>
+            <a:r>
+              <a:rPr lang="en-US" sz="3200" dirty="0">
+                <a:latin typeface="Arial" panose="020B0604020202020204" pitchFamily="34" charset="0"/>
+                <a:cs typeface="Arial" panose="020B0604020202020204" pitchFamily="34" charset="0"/>
+              </a:rPr>
+              <a:t>bank checks sorted by account #</a:t>
+            </a:r>
+          </a:p>
+          <a:p>
+            <a:pPr lvl="1"/>
+            <a:r>
+              <a:rPr lang="en-US" sz="3200" dirty="0">
+                <a:latin typeface="Arial" panose="020B0604020202020204" pitchFamily="34" charset="0"/>
+                <a:cs typeface="Arial" panose="020B0604020202020204" pitchFamily="34" charset="0"/>
+              </a:rPr>
+              <a:t>addresses in a mailing list sorted by zip code</a:t>
+            </a:r>
+          </a:p>
+          <a:p>
+            <a:pPr lvl="1"/>
+            <a:r>
+              <a:rPr lang="en-US" sz="3200" dirty="0">
+                <a:latin typeface="Arial" panose="020B0604020202020204" pitchFamily="34" charset="0"/>
+                <a:cs typeface="Arial" panose="020B0604020202020204" pitchFamily="34" charset="0"/>
+              </a:rPr>
+              <a:t>hits found by a search engine sorted by relevance</a:t>
+            </a:r>
+          </a:p>
+          <a:p>
+            <a:pPr lvl="1"/>
+            <a:r>
+              <a:rPr lang="en-US" sz="3200" dirty="0">
+                <a:latin typeface="Arial" panose="020B0604020202020204" pitchFamily="34" charset="0"/>
+                <a:cs typeface="Arial" panose="020B0604020202020204" pitchFamily="34" charset="0"/>
+              </a:rPr>
+              <a:t>credit card transactions sorted by date</a:t>
+            </a:r>
+          </a:p>
+        </p:txBody>
+      </p:sp>
+    </p:spTree>
+  </p:cSld>
+  <p:clrMapOvr>
+    <a:masterClrMapping/>
+  </p:clrMapOvr>
+</p:sld>
+</file>
+
+<file path=ppt/slides/slide30.xml><?xml version="1.0" encoding="utf-8"?>
+<p:sld xmlns:a="http://schemas.openxmlformats.org/drawingml/2006/main" xmlns:r="http://schemas.openxmlformats.org/officeDocument/2006/relationships" xmlns:p="http://schemas.openxmlformats.org/presentationml/2006/main">
+  <p:cSld>
     <p:bg>
       <p:bgPr>
         <a:solidFill>
@@ -41397,133 +42212,7 @@
 </p:sld>
 </file>
 
-<file path=ppt/slides/slide3.xml><?xml version="1.0" encoding="utf-8"?>
-<p:sld xmlns:a="http://schemas.openxmlformats.org/drawingml/2006/main" xmlns:r="http://schemas.openxmlformats.org/officeDocument/2006/relationships" xmlns:p="http://schemas.openxmlformats.org/presentationml/2006/main">
-  <p:cSld>
-    <p:spTree>
-      <p:nvGrpSpPr>
-        <p:cNvPr id="1" name=""/>
-        <p:cNvGrpSpPr/>
-        <p:nvPr/>
-      </p:nvGrpSpPr>
-      <p:grpSpPr>
-        <a:xfrm>
-          <a:off x="0" y="0"/>
-          <a:ext cx="0" cy="0"/>
-          <a:chOff x="0" y="0"/>
-          <a:chExt cx="0" cy="0"/>
-        </a:xfrm>
-      </p:grpSpPr>
-      <p:sp>
-        <p:nvSpPr>
-          <p:cNvPr id="7171" name="Rectangle 2"/>
-          <p:cNvSpPr>
-            <a:spLocks noGrp="1" noChangeArrowheads="1"/>
-          </p:cNvSpPr>
-          <p:nvPr>
-            <p:ph type="title"/>
-          </p:nvPr>
-        </p:nvSpPr>
-        <p:spPr>
-          <a:xfrm>
-            <a:off x="152400" y="609600"/>
-            <a:ext cx="8686800" cy="1143000"/>
-          </a:xfrm>
-        </p:spPr>
-        <p:txBody>
-          <a:bodyPr/>
-          <a:lstStyle/>
-          <a:p>
-            <a:r>
-              <a:rPr lang="en-US" dirty="0">
-                <a:latin typeface="Arial" panose="020B0604020202020204" pitchFamily="34" charset="0"/>
-                <a:cs typeface="Arial" panose="020B0604020202020204" pitchFamily="34" charset="0"/>
-              </a:rPr>
-              <a:t>Examples of sorting applications:</a:t>
-            </a:r>
-          </a:p>
-        </p:txBody>
-      </p:sp>
-      <p:sp>
-        <p:nvSpPr>
-          <p:cNvPr id="7172" name="Rectangle 3"/>
-          <p:cNvSpPr>
-            <a:spLocks noGrp="1" noChangeArrowheads="1"/>
-          </p:cNvSpPr>
-          <p:nvPr>
-            <p:ph type="body" sz="half" idx="1"/>
-          </p:nvPr>
-        </p:nvSpPr>
-        <p:spPr>
-          <a:xfrm>
-            <a:off x="0" y="1885950"/>
-            <a:ext cx="8991600" cy="4514850"/>
-          </a:xfrm>
-        </p:spPr>
-        <p:txBody>
-          <a:bodyPr/>
-          <a:lstStyle/>
-          <a:p>
-            <a:pPr lvl="1"/>
-            <a:r>
-              <a:rPr lang="en-US" sz="3200" dirty="0">
-                <a:latin typeface="Arial" panose="020B0604020202020204" pitchFamily="34" charset="0"/>
-                <a:cs typeface="Arial" panose="020B0604020202020204" pitchFamily="34" charset="0"/>
-              </a:rPr>
-              <a:t>a directory of files sorted by name or date</a:t>
-            </a:r>
-          </a:p>
-          <a:p>
-            <a:pPr lvl="1"/>
-            <a:r>
-              <a:rPr lang="en-US" sz="3200" dirty="0">
-                <a:latin typeface="Arial" panose="020B0604020202020204" pitchFamily="34" charset="0"/>
-                <a:cs typeface="Arial" panose="020B0604020202020204" pitchFamily="34" charset="0"/>
-              </a:rPr>
-              <a:t>bank checks sorted by account #</a:t>
-            </a:r>
-          </a:p>
-          <a:p>
-            <a:pPr lvl="1"/>
-            <a:r>
-              <a:rPr lang="en-US" sz="3200" dirty="0">
-                <a:latin typeface="Arial" panose="020B0604020202020204" pitchFamily="34" charset="0"/>
-                <a:cs typeface="Arial" panose="020B0604020202020204" pitchFamily="34" charset="0"/>
-              </a:rPr>
-              <a:t>addresses in a mailing list sorted by zip code</a:t>
-            </a:r>
-          </a:p>
-          <a:p>
-            <a:pPr lvl="1"/>
-            <a:r>
-              <a:rPr lang="en-US" sz="3200" dirty="0">
-                <a:latin typeface="Arial" panose="020B0604020202020204" pitchFamily="34" charset="0"/>
-                <a:cs typeface="Arial" panose="020B0604020202020204" pitchFamily="34" charset="0"/>
-              </a:rPr>
-              <a:t>hits found by a search engine sorted by relevance</a:t>
-            </a:r>
-          </a:p>
-          <a:p>
-            <a:pPr lvl="1"/>
-            <a:r>
-              <a:rPr lang="en-US" sz="3200" dirty="0">
-                <a:latin typeface="Arial" panose="020B0604020202020204" pitchFamily="34" charset="0"/>
-                <a:cs typeface="Arial" panose="020B0604020202020204" pitchFamily="34" charset="0"/>
-              </a:rPr>
-              <a:t>credit card transactions sorted by date</a:t>
-            </a:r>
-          </a:p>
-        </p:txBody>
-      </p:sp>
-    </p:spTree>
-  </p:cSld>
-  <p:clrMapOvr>
-    <a:masterClrMapping/>
-  </p:clrMapOvr>
-</p:sld>
-</file>
-
-<file path=ppt/slides/slide30.xml><?xml version="1.0" encoding="utf-8"?>
+<file path=ppt/slides/slide31.xml><?xml version="1.0" encoding="utf-8"?>
 <p:sld xmlns:a="http://schemas.openxmlformats.org/drawingml/2006/main" xmlns:r="http://schemas.openxmlformats.org/officeDocument/2006/relationships" xmlns:p="http://schemas.openxmlformats.org/presentationml/2006/main">
   <p:cSld>
     <p:bg>
@@ -41745,7 +42434,7 @@
 </p:sld>
 </file>
 
-<file path=ppt/slides/slide31.xml><?xml version="1.0" encoding="utf-8"?>
+<file path=ppt/slides/slide32.xml><?xml version="1.0" encoding="utf-8"?>
 <p:sld xmlns:a="http://schemas.openxmlformats.org/drawingml/2006/main" xmlns:r="http://schemas.openxmlformats.org/officeDocument/2006/relationships" xmlns:p="http://schemas.openxmlformats.org/presentationml/2006/main">
   <p:cSld>
     <p:bg>
@@ -41944,7 +42633,7 @@
 </p:sld>
 </file>
 
-<file path=ppt/slides/slide32.xml><?xml version="1.0" encoding="utf-8"?>
+<file path=ppt/slides/slide33.xml><?xml version="1.0" encoding="utf-8"?>
 <p:sld xmlns:a="http://schemas.openxmlformats.org/drawingml/2006/main" xmlns:r="http://schemas.openxmlformats.org/officeDocument/2006/relationships" xmlns:p="http://schemas.openxmlformats.org/presentationml/2006/main">
   <p:cSld>
     <p:bg>
@@ -42155,7 +42844,7 @@
 </p:sld>
 </file>
 
-<file path=ppt/slides/slide33.xml><?xml version="1.0" encoding="utf-8"?>
+<file path=ppt/slides/slide34.xml><?xml version="1.0" encoding="utf-8"?>
 <p:sld xmlns:a="http://schemas.openxmlformats.org/drawingml/2006/main" xmlns:r="http://schemas.openxmlformats.org/officeDocument/2006/relationships" xmlns:p="http://schemas.openxmlformats.org/presentationml/2006/main">
   <p:cSld>
     <p:spTree>
@@ -43175,7 +43864,7 @@
 </p:sld>
 </file>
 
-<file path=ppt/slides/slide34.xml><?xml version="1.0" encoding="utf-8"?>
+<file path=ppt/slides/slide35.xml><?xml version="1.0" encoding="utf-8"?>
 <p:sld xmlns:a="http://schemas.openxmlformats.org/drawingml/2006/main" xmlns:r="http://schemas.openxmlformats.org/officeDocument/2006/relationships" xmlns:p="http://schemas.openxmlformats.org/presentationml/2006/main">
   <p:cSld>
     <p:spTree>
@@ -43772,7 +44461,7 @@
 </p:sld>
 </file>
 
-<file path=ppt/slides/slide35.xml><?xml version="1.0" encoding="utf-8"?>
+<file path=ppt/slides/slide36.xml><?xml version="1.0" encoding="utf-8"?>
 <p:sld xmlns:a="http://schemas.openxmlformats.org/drawingml/2006/main" xmlns:r="http://schemas.openxmlformats.org/officeDocument/2006/relationships" xmlns:p="http://schemas.openxmlformats.org/presentationml/2006/main">
   <p:cSld>
     <p:spTree>
@@ -44465,7 +45154,7 @@
 </p:sld>
 </file>
 
-<file path=ppt/slides/slide36.xml><?xml version="1.0" encoding="utf-8"?>
+<file path=ppt/slides/slide37.xml><?xml version="1.0" encoding="utf-8"?>
 <p:sld xmlns:a="http://schemas.openxmlformats.org/drawingml/2006/main" xmlns:r="http://schemas.openxmlformats.org/officeDocument/2006/relationships" xmlns:p="http://schemas.openxmlformats.org/presentationml/2006/main">
   <p:cSld>
     <p:bg>

</xml_diff>